<commit_message>
Update presentation with final revisions
</commit_message>
<xml_diff>
--- a/presentation.pptx
+++ b/presentation.pptx
@@ -508,12 +508,6 @@
             <c:idx val="0"/>
             <c:invertIfNegative val="0"/>
             <c:bubble3D val="0"/>
-            <c:spPr>
-              <a:solidFill>
-                <a:srgbClr val="E8A33D"/>
-              </a:solidFill>
-              <a:effectLst/>
-            </c:spPr>
             <c:extLst>
               <c:ext xmlns:c16="http://schemas.microsoft.com/office/drawing/2014/chart" uri="{C3380CC4-5D6E-409C-BE32-E72D297353CC}">
                 <c16:uniqueId val="{00000001-18EB-234B-888B-A28A601808CB}"/>
@@ -6676,45 +6670,6 @@
           </a:p>
         </p:txBody>
       </p:sp>
-      <p:sp>
-        <p:nvSpPr>
-          <p:cNvPr id="4" name="Text 2"/>
-          <p:cNvSpPr txBox="1"/>
-          <p:nvPr/>
-        </p:nvSpPr>
-        <p:spPr>
-          <a:xfrm>
-            <a:off x="548640" y="6400800"/>
-            <a:ext cx="11091672" cy="274320"/>
-          </a:xfrm>
-          <a:prstGeom prst="rect">
-            <a:avLst/>
-          </a:prstGeom>
-          <a:noFill/>
-          <a:ln/>
-        </p:spPr>
-        <p:txBody>
-          <a:bodyPr wrap="square" lIns="0" tIns="0" rIns="0" bIns="0" rtlCol="0" anchor="ctr"/>
-          <a:lstStyle/>
-          <a:p>
-            <a:pPr marL="0" indent="0" algn="r">
-              <a:buNone/>
-            </a:pPr>
-            <a:r>
-              <a:rPr lang="en-US" sz="900" dirty="0">
-                <a:solidFill>
-                  <a:srgbClr val="8A94A6"/>
-                </a:solidFill>
-                <a:latin typeface="Calibri" pitchFamily="34" charset="0"/>
-                <a:ea typeface="Calibri" pitchFamily="34" charset="-122"/>
-                <a:cs typeface="Calibri" pitchFamily="34" charset="-120"/>
-              </a:rPr>
-              <a:t>Sude Bozkurt · Borusan Otomotiv case study · 14</a:t>
-            </a:r>
-            <a:endParaRPr lang="en-US" sz="900" dirty="0"/>
-          </a:p>
-        </p:txBody>
-      </p:sp>
     </p:spTree>
   </p:cSld>
   <p:clrMapOvr>
@@ -7470,45 +7425,6 @@
           </a:p>
         </p:txBody>
       </p:sp>
-      <p:sp>
-        <p:nvSpPr>
-          <p:cNvPr id="14" name="Text 12"/>
-          <p:cNvSpPr txBox="1"/>
-          <p:nvPr/>
-        </p:nvSpPr>
-        <p:spPr>
-          <a:xfrm>
-            <a:off x="548640" y="6400800"/>
-            <a:ext cx="11091672" cy="274320"/>
-          </a:xfrm>
-          <a:prstGeom prst="rect">
-            <a:avLst/>
-          </a:prstGeom>
-          <a:noFill/>
-          <a:ln/>
-        </p:spPr>
-        <p:txBody>
-          <a:bodyPr wrap="square" lIns="0" tIns="0" rIns="0" bIns="0" rtlCol="0" anchor="ctr"/>
-          <a:lstStyle/>
-          <a:p>
-            <a:pPr marL="0" indent="0" algn="r">
-              <a:buNone/>
-            </a:pPr>
-            <a:r>
-              <a:rPr lang="en-US" sz="900" dirty="0">
-                <a:solidFill>
-                  <a:srgbClr val="9AA3AE"/>
-                </a:solidFill>
-                <a:latin typeface="Calibri" pitchFamily="34" charset="0"/>
-                <a:ea typeface="Calibri" pitchFamily="34" charset="-122"/>
-                <a:cs typeface="Calibri" pitchFamily="34" charset="-120"/>
-              </a:rPr>
-              <a:t>Sude Bozkurt · Borusan Otomotiv case study · 15</a:t>
-            </a:r>
-            <a:endParaRPr lang="en-US" sz="900" dirty="0"/>
-          </a:p>
-        </p:txBody>
-      </p:sp>
     </p:spTree>
   </p:cSld>
   <p:clrMapOvr>
@@ -7688,118 +7604,6 @@
           </a:p>
         </p:txBody>
       </p:sp>
-      <p:sp>
-        <p:nvSpPr>
-          <p:cNvPr id="7" name="Text 5"/>
-          <p:cNvSpPr txBox="1"/>
-          <p:nvPr/>
-        </p:nvSpPr>
-        <p:spPr>
-          <a:xfrm>
-            <a:off x="6492240" y="1874520"/>
-            <a:ext cx="4937760" cy="4023360"/>
-          </a:xfrm>
-          <a:prstGeom prst="rect">
-            <a:avLst/>
-          </a:prstGeom>
-          <a:noFill/>
-          <a:ln/>
-        </p:spPr>
-        <p:txBody>
-          <a:bodyPr wrap="square" lIns="0" tIns="0" rIns="0" bIns="0" rtlCol="0" anchor="ctr"/>
-          <a:lstStyle/>
-          <a:p>
-            <a:pPr marL="0" indent="0" algn="ctr">
-              <a:buNone/>
-            </a:pPr>
-            <a:r>
-              <a:rPr lang="en-US" sz="1100" b="1" dirty="0">
-                <a:solidFill>
-                  <a:srgbClr val="E8A33D"/>
-                </a:solidFill>
-                <a:latin typeface="Calibri" pitchFamily="34" charset="0"/>
-                <a:ea typeface="Calibri" pitchFamily="34" charset="-122"/>
-                <a:cs typeface="Calibri" pitchFamily="34" charset="-120"/>
-              </a:rPr>
-              <a:t>SCREENSHOT PLACEHOLDER</a:t>
-            </a:r>
-            <a:endParaRPr lang="en-US" sz="1100" dirty="0"/>
-          </a:p>
-          <a:p>
-            <a:pPr marL="0" indent="0" algn="ctr">
-              <a:buNone/>
-            </a:pPr>
-            <a:r>
-              <a:rPr lang="en-US" sz="1200" dirty="0">
-                <a:solidFill>
-                  <a:srgbClr val="2E3540"/>
-                </a:solidFill>
-                <a:latin typeface="Calibri" pitchFamily="34" charset="0"/>
-                <a:ea typeface="Calibri" pitchFamily="34" charset="-122"/>
-                <a:cs typeface="Calibri" pitchFamily="34" charset="-120"/>
-              </a:rPr>
-              <a:t>Monitor view of a successful run with per-activity durations</a:t>
-            </a:r>
-            <a:endParaRPr lang="en-US" sz="1100" dirty="0"/>
-          </a:p>
-          <a:p>
-            <a:pPr marL="0" indent="0" algn="ctr">
-              <a:buNone/>
-            </a:pPr>
-            <a:r>
-              <a:rPr lang="en-US" sz="1000" i="1" dirty="0">
-                <a:solidFill>
-                  <a:srgbClr val="5B6573"/>
-                </a:solidFill>
-                <a:latin typeface="Calibri" pitchFamily="34" charset="0"/>
-                <a:ea typeface="Calibri" pitchFamily="34" charset="-122"/>
-                <a:cs typeface="Calibri" pitchFamily="34" charset="-120"/>
-              </a:rPr>
-              <a:t>save as report/screenshots/16b_pipeline_monitor.png</a:t>
-            </a:r>
-            <a:endParaRPr lang="en-US" sz="1100" dirty="0"/>
-          </a:p>
-        </p:txBody>
-      </p:sp>
-      <p:sp>
-        <p:nvSpPr>
-          <p:cNvPr id="8" name="Text 6"/>
-          <p:cNvSpPr txBox="1"/>
-          <p:nvPr/>
-        </p:nvSpPr>
-        <p:spPr>
-          <a:xfrm>
-            <a:off x="548640" y="6400800"/>
-            <a:ext cx="11091672" cy="274320"/>
-          </a:xfrm>
-          <a:prstGeom prst="rect">
-            <a:avLst/>
-          </a:prstGeom>
-          <a:noFill/>
-          <a:ln/>
-        </p:spPr>
-        <p:txBody>
-          <a:bodyPr wrap="square" lIns="0" tIns="0" rIns="0" bIns="0" rtlCol="0" anchor="ctr"/>
-          <a:lstStyle/>
-          <a:p>
-            <a:pPr marL="0" indent="0" algn="r">
-              <a:buNone/>
-            </a:pPr>
-            <a:r>
-              <a:rPr lang="en-US" sz="900" dirty="0">
-                <a:solidFill>
-                  <a:srgbClr val="9AA3AE"/>
-                </a:solidFill>
-                <a:latin typeface="Calibri" pitchFamily="34" charset="0"/>
-                <a:ea typeface="Calibri" pitchFamily="34" charset="-122"/>
-                <a:cs typeface="Calibri" pitchFamily="34" charset="-120"/>
-              </a:rPr>
-              <a:t>Sude Bozkurt · Borusan Otomotiv case study · 16</a:t>
-            </a:r>
-            <a:endParaRPr lang="en-US" sz="900" dirty="0"/>
-          </a:p>
-        </p:txBody>
-      </p:sp>
       <p:pic>
         <p:nvPicPr>
           <p:cNvPr id="9" name="Picture 8" descr="16a_pipeline_canvas.png"/>
@@ -7817,8 +7621,38 @@
         </p:blipFill>
         <p:spPr>
           <a:xfrm>
-            <a:off x="655320" y="1874520"/>
+            <a:off x="579120" y="1828800"/>
             <a:ext cx="5273040" cy="4023360"/>
+          </a:xfrm>
+          <a:prstGeom prst="rect">
+            <a:avLst/>
+          </a:prstGeom>
+        </p:spPr>
+      </p:pic>
+      <p:pic>
+        <p:nvPicPr>
+          <p:cNvPr id="10" name="Picture 9">
+            <a:extLst>
+              <a:ext uri="{FF2B5EF4-FFF2-40B4-BE49-F238E27FC236}">
+                <a16:creationId xmlns:a16="http://schemas.microsoft.com/office/drawing/2014/main" id="{11686954-2B6A-5C97-203D-B99240E9357A}"/>
+              </a:ext>
+            </a:extLst>
+          </p:cNvPr>
+          <p:cNvPicPr>
+            <a:picLocks noChangeAspect="1"/>
+          </p:cNvPicPr>
+          <p:nvPr/>
+        </p:nvPicPr>
+        <p:blipFill>
+          <a:blip r:embed="rId4"/>
+          <a:stretch>
+            <a:fillRect/>
+          </a:stretch>
+        </p:blipFill>
+        <p:spPr>
+          <a:xfrm>
+            <a:off x="6492240" y="3080724"/>
+            <a:ext cx="4937760" cy="1702392"/>
           </a:xfrm>
           <a:prstGeom prst="rect">
             <a:avLst/>

</xml_diff>